<commit_message>
Finish except medium.com down
</commit_message>
<xml_diff>
--- a/ppt/RAG13-FineTuning.pptx
+++ b/ppt/RAG13-FineTuning.pptx
@@ -5,10 +5,10 @@
     <p:sldMasterId id="2147483653" r:id="rId1"/>
   </p:sldMasterIdLst>
   <p:notesMasterIdLst>
-    <p:notesMasterId r:id="rId17"/>
+    <p:notesMasterId r:id="rId26"/>
   </p:notesMasterIdLst>
   <p:handoutMasterIdLst>
-    <p:handoutMasterId r:id="rId18"/>
+    <p:handoutMasterId r:id="rId27"/>
   </p:handoutMasterIdLst>
   <p:sldIdLst>
     <p:sldId id="264" r:id="rId2"/>
@@ -26,6 +26,15 @@
     <p:sldId id="318" r:id="rId14"/>
     <p:sldId id="278" r:id="rId15"/>
     <p:sldId id="279" r:id="rId16"/>
+    <p:sldId id="341" r:id="rId17"/>
+    <p:sldId id="342" r:id="rId18"/>
+    <p:sldId id="344" r:id="rId19"/>
+    <p:sldId id="343" r:id="rId20"/>
+    <p:sldId id="345" r:id="rId21"/>
+    <p:sldId id="348" r:id="rId22"/>
+    <p:sldId id="349" r:id="rId23"/>
+    <p:sldId id="346" r:id="rId24"/>
+    <p:sldId id="347" r:id="rId25"/>
   </p:sldIdLst>
   <p:sldSz cx="9144000" cy="6858000" type="screen4x3"/>
   <p:notesSz cx="6648450" cy="9782175"/>
@@ -4622,6 +4631,626 @@
 </p:sld>
 </file>
 
+<file path=ppt/slides/slide16.xml><?xml version="1.0" encoding="utf-8"?>
+<p:sld xmlns:a="http://schemas.openxmlformats.org/drawingml/2006/main" xmlns:r="http://schemas.openxmlformats.org/officeDocument/2006/relationships" xmlns:p="http://schemas.openxmlformats.org/presentationml/2006/main">
+  <p:cSld>
+    <p:spTree>
+      <p:nvGrpSpPr>
+        <p:cNvPr id="1" name=""/>
+        <p:cNvGrpSpPr/>
+        <p:nvPr/>
+      </p:nvGrpSpPr>
+      <p:grpSpPr>
+        <a:xfrm>
+          <a:off x="0" y="0"/>
+          <a:ext cx="0" cy="0"/>
+          <a:chOff x="0" y="0"/>
+          <a:chExt cx="0" cy="0"/>
+        </a:xfrm>
+      </p:grpSpPr>
+      <p:sp>
+        <p:nvSpPr>
+          <p:cNvPr id="2" name="Titre 1">
+            <a:extLst>
+              <a:ext uri="{FF2B5EF4-FFF2-40B4-BE49-F238E27FC236}">
+                <a16:creationId xmlns:a16="http://schemas.microsoft.com/office/drawing/2014/main" id="{4801FF74-64E2-9BDB-B843-7029D6FBFB3A}"/>
+              </a:ext>
+            </a:extLst>
+          </p:cNvPr>
+          <p:cNvSpPr>
+            <a:spLocks noGrp="1"/>
+          </p:cNvSpPr>
+          <p:nvPr>
+            <p:ph type="title"/>
+          </p:nvPr>
+        </p:nvSpPr>
+        <p:spPr/>
+        <p:txBody>
+          <a:bodyPr/>
+          <a:lstStyle/>
+          <a:p>
+            <a:r>
+              <a:rPr lang="fr-FR" dirty="0" err="1"/>
+              <a:t>DataSet</a:t>
+            </a:r>
+            <a:endParaRPr lang="fr-FR" dirty="0"/>
+          </a:p>
+        </p:txBody>
+      </p:sp>
+      <p:sp>
+        <p:nvSpPr>
+          <p:cNvPr id="3" name="Espace réservé du contenu 2">
+            <a:extLst>
+              <a:ext uri="{FF2B5EF4-FFF2-40B4-BE49-F238E27FC236}">
+                <a16:creationId xmlns:a16="http://schemas.microsoft.com/office/drawing/2014/main" id="{B82644AF-FF79-7A21-BDCF-D230A42DA872}"/>
+              </a:ext>
+            </a:extLst>
+          </p:cNvPr>
+          <p:cNvSpPr>
+            <a:spLocks noGrp="1"/>
+          </p:cNvSpPr>
+          <p:nvPr>
+            <p:ph idx="1"/>
+          </p:nvPr>
+        </p:nvSpPr>
+        <p:spPr/>
+        <p:txBody>
+          <a:bodyPr/>
+          <a:lstStyle/>
+          <a:p>
+            <a:r>
+              <a:rPr lang="fr-FR" dirty="0"/>
+              <a:t>Apprentissage supervisé</a:t>
+            </a:r>
+          </a:p>
+          <a:p>
+            <a:pPr lvl="1"/>
+            <a:r>
+              <a:rPr lang="fr-FR" dirty="0"/>
+              <a:t>Avoir un </a:t>
+            </a:r>
+            <a:r>
+              <a:rPr lang="fr-FR" dirty="0" err="1"/>
+              <a:t>dataset</a:t>
+            </a:r>
+            <a:r>
+              <a:rPr lang="fr-FR" dirty="0"/>
+              <a:t> avec question &amp; réponses attendues</a:t>
+            </a:r>
+          </a:p>
+          <a:p>
+            <a:pPr lvl="1"/>
+            <a:r>
+              <a:rPr lang="fr-FR" dirty="0"/>
+              <a:t>En CSV ou JSON</a:t>
+            </a:r>
+          </a:p>
+          <a:p>
+            <a:pPr lvl="1"/>
+            <a:r>
+              <a:rPr lang="fr-FR" dirty="0"/>
+              <a:t>Plusieurs Mo (idéalement &gt; 100Mo)</a:t>
+            </a:r>
+          </a:p>
+          <a:p>
+            <a:pPr lvl="1"/>
+            <a:r>
+              <a:rPr lang="fr-FR" dirty="0"/>
+              <a:t>Découpage du </a:t>
+            </a:r>
+            <a:r>
+              <a:rPr lang="fr-FR" dirty="0" err="1"/>
+              <a:t>dataset</a:t>
+            </a:r>
+            <a:r>
+              <a:rPr lang="fr-FR" dirty="0"/>
+              <a:t> en 2 parties</a:t>
+            </a:r>
+          </a:p>
+          <a:p>
+            <a:pPr lvl="1"/>
+            <a:r>
+              <a:rPr lang="fr-FR" dirty="0" err="1"/>
+              <a:t>TrainingSet</a:t>
+            </a:r>
+            <a:r>
+              <a:rPr lang="fr-FR" dirty="0"/>
+              <a:t> et </a:t>
+            </a:r>
+            <a:r>
+              <a:rPr lang="fr-FR" dirty="0" err="1"/>
+              <a:t>TestingSet</a:t>
+            </a:r>
+            <a:endParaRPr lang="fr-FR" dirty="0"/>
+          </a:p>
+        </p:txBody>
+      </p:sp>
+    </p:spTree>
+    <p:extLst>
+      <p:ext uri="{BB962C8B-B14F-4D97-AF65-F5344CB8AC3E}">
+        <p14:creationId xmlns:p14="http://schemas.microsoft.com/office/powerpoint/2010/main" val="2775197929"/>
+      </p:ext>
+    </p:extLst>
+  </p:cSld>
+  <p:clrMapOvr>
+    <a:masterClrMapping/>
+  </p:clrMapOvr>
+</p:sld>
+</file>
+
+<file path=ppt/slides/slide17.xml><?xml version="1.0" encoding="utf-8"?>
+<p:sld xmlns:a="http://schemas.openxmlformats.org/drawingml/2006/main" xmlns:r="http://schemas.openxmlformats.org/officeDocument/2006/relationships" xmlns:p="http://schemas.openxmlformats.org/presentationml/2006/main">
+  <p:cSld>
+    <p:spTree>
+      <p:nvGrpSpPr>
+        <p:cNvPr id="1" name=""/>
+        <p:cNvGrpSpPr/>
+        <p:nvPr/>
+      </p:nvGrpSpPr>
+      <p:grpSpPr>
+        <a:xfrm>
+          <a:off x="0" y="0"/>
+          <a:ext cx="0" cy="0"/>
+          <a:chOff x="0" y="0"/>
+          <a:chExt cx="0" cy="0"/>
+        </a:xfrm>
+      </p:grpSpPr>
+      <p:sp>
+        <p:nvSpPr>
+          <p:cNvPr id="2" name="Titre 1">
+            <a:extLst>
+              <a:ext uri="{FF2B5EF4-FFF2-40B4-BE49-F238E27FC236}">
+                <a16:creationId xmlns:a16="http://schemas.microsoft.com/office/drawing/2014/main" id="{7E8F59BE-47C0-5CA5-7E98-F83C65199B6F}"/>
+              </a:ext>
+            </a:extLst>
+          </p:cNvPr>
+          <p:cNvSpPr>
+            <a:spLocks noGrp="1"/>
+          </p:cNvSpPr>
+          <p:nvPr>
+            <p:ph type="title"/>
+          </p:nvPr>
+        </p:nvSpPr>
+        <p:spPr/>
+        <p:txBody>
+          <a:bodyPr/>
+          <a:lstStyle/>
+          <a:p>
+            <a:r>
+              <a:rPr lang="fr-FR" dirty="0"/>
+              <a:t>Tarification</a:t>
+            </a:r>
+          </a:p>
+        </p:txBody>
+      </p:sp>
+      <p:sp>
+        <p:nvSpPr>
+          <p:cNvPr id="3" name="Espace réservé du contenu 2">
+            <a:extLst>
+              <a:ext uri="{FF2B5EF4-FFF2-40B4-BE49-F238E27FC236}">
+                <a16:creationId xmlns:a16="http://schemas.microsoft.com/office/drawing/2014/main" id="{92CEE73E-EEA1-499D-8683-ADA1E6F866FE}"/>
+              </a:ext>
+            </a:extLst>
+          </p:cNvPr>
+          <p:cNvSpPr>
+            <a:spLocks noGrp="1"/>
+          </p:cNvSpPr>
+          <p:nvPr>
+            <p:ph idx="1"/>
+          </p:nvPr>
+        </p:nvSpPr>
+        <p:spPr/>
+        <p:txBody>
+          <a:bodyPr/>
+          <a:lstStyle/>
+          <a:p>
+            <a:r>
+              <a:rPr lang="fr-FR" dirty="0"/>
+              <a:t>GPT 4.1 nano</a:t>
+            </a:r>
+          </a:p>
+          <a:p>
+            <a:pPr lvl="1"/>
+            <a:r>
+              <a:rPr lang="fr-FR" dirty="0"/>
+              <a:t>1.5$ / 1MToken + cout fixe de 4$ par job + 2$ par mois</a:t>
+            </a:r>
+          </a:p>
+          <a:p>
+            <a:r>
+              <a:rPr lang="fr-FR" dirty="0"/>
+              <a:t>GPT 4.1</a:t>
+            </a:r>
+          </a:p>
+          <a:p>
+            <a:pPr lvl="1"/>
+            <a:r>
+              <a:rPr lang="fr-FR" dirty="0"/>
+              <a:t>25$ / 1MToken</a:t>
+            </a:r>
+          </a:p>
+          <a:p>
+            <a:r>
+              <a:rPr lang="fr-FR" dirty="0"/>
+              <a:t>GPT 5</a:t>
+            </a:r>
+          </a:p>
+          <a:p>
+            <a:pPr lvl="1"/>
+            <a:r>
+              <a:rPr lang="fr-FR" dirty="0"/>
+              <a:t>10K$ / 1MToken</a:t>
+            </a:r>
+          </a:p>
+          <a:p>
+            <a:r>
+              <a:rPr lang="fr-FR" dirty="0"/>
+              <a:t>Pour 1 </a:t>
+            </a:r>
+            <a:r>
+              <a:rPr lang="fr-FR" dirty="0" err="1"/>
+              <a:t>dataset</a:t>
+            </a:r>
+            <a:r>
+              <a:rPr lang="fr-FR" dirty="0"/>
+              <a:t> de 100Mo</a:t>
+            </a:r>
+          </a:p>
+          <a:p>
+            <a:pPr lvl="1"/>
+            <a:r>
+              <a:rPr lang="fr-FR" dirty="0"/>
+              <a:t>50MToken</a:t>
+            </a:r>
+          </a:p>
+          <a:p>
+            <a:pPr lvl="1"/>
+            <a:r>
+              <a:rPr lang="fr-FR" dirty="0"/>
+              <a:t>2 </a:t>
+            </a:r>
+            <a:r>
+              <a:rPr lang="fr-FR" dirty="0" err="1"/>
+              <a:t>epochs</a:t>
+            </a:r>
+            <a:r>
+              <a:rPr lang="fr-FR" dirty="0"/>
+              <a:t> minimum</a:t>
+            </a:r>
+          </a:p>
+          <a:p>
+            <a:pPr lvl="1"/>
+            <a:r>
+              <a:rPr lang="fr-FR"/>
+              <a:t>De 80$ </a:t>
+            </a:r>
+            <a:r>
+              <a:rPr lang="fr-FR" dirty="0"/>
+              <a:t>à 10K$</a:t>
+            </a:r>
+          </a:p>
+        </p:txBody>
+      </p:sp>
+    </p:spTree>
+    <p:extLst>
+      <p:ext uri="{BB962C8B-B14F-4D97-AF65-F5344CB8AC3E}">
+        <p14:creationId xmlns:p14="http://schemas.microsoft.com/office/powerpoint/2010/main" val="3279174304"/>
+      </p:ext>
+    </p:extLst>
+  </p:cSld>
+  <p:clrMapOvr>
+    <a:masterClrMapping/>
+  </p:clrMapOvr>
+</p:sld>
+</file>
+
+<file path=ppt/slides/slide18.xml><?xml version="1.0" encoding="utf-8"?>
+<p:sld xmlns:a="http://schemas.openxmlformats.org/drawingml/2006/main" xmlns:r="http://schemas.openxmlformats.org/officeDocument/2006/relationships" xmlns:p="http://schemas.openxmlformats.org/presentationml/2006/main">
+  <p:cSld>
+    <p:spTree>
+      <p:nvGrpSpPr>
+        <p:cNvPr id="1" name=""/>
+        <p:cNvGrpSpPr/>
+        <p:nvPr/>
+      </p:nvGrpSpPr>
+      <p:grpSpPr>
+        <a:xfrm>
+          <a:off x="0" y="0"/>
+          <a:ext cx="0" cy="0"/>
+          <a:chOff x="0" y="0"/>
+          <a:chExt cx="0" cy="0"/>
+        </a:xfrm>
+      </p:grpSpPr>
+      <p:sp>
+        <p:nvSpPr>
+          <p:cNvPr id="2" name="Titre 1">
+            <a:extLst>
+              <a:ext uri="{FF2B5EF4-FFF2-40B4-BE49-F238E27FC236}">
+                <a16:creationId xmlns:a16="http://schemas.microsoft.com/office/drawing/2014/main" id="{2674BD0A-B3C8-247F-4898-1AECAD260132}"/>
+              </a:ext>
+            </a:extLst>
+          </p:cNvPr>
+          <p:cNvSpPr>
+            <a:spLocks noGrp="1"/>
+          </p:cNvSpPr>
+          <p:nvPr>
+            <p:ph type="title"/>
+          </p:nvPr>
+        </p:nvSpPr>
+        <p:spPr/>
+        <p:txBody>
+          <a:bodyPr/>
+          <a:lstStyle/>
+          <a:p>
+            <a:r>
+              <a:rPr lang="fr-FR" dirty="0"/>
+              <a:t>Optimisation</a:t>
+            </a:r>
+          </a:p>
+        </p:txBody>
+      </p:sp>
+      <p:sp>
+        <p:nvSpPr>
+          <p:cNvPr id="3" name="Espace réservé du contenu 2">
+            <a:extLst>
+              <a:ext uri="{FF2B5EF4-FFF2-40B4-BE49-F238E27FC236}">
+                <a16:creationId xmlns:a16="http://schemas.microsoft.com/office/drawing/2014/main" id="{7EEAA434-2501-9ACF-347A-DBB34891A72A}"/>
+              </a:ext>
+            </a:extLst>
+          </p:cNvPr>
+          <p:cNvSpPr>
+            <a:spLocks noGrp="1"/>
+          </p:cNvSpPr>
+          <p:nvPr>
+            <p:ph idx="1"/>
+          </p:nvPr>
+        </p:nvSpPr>
+        <p:spPr/>
+        <p:txBody>
+          <a:bodyPr/>
+          <a:lstStyle/>
+          <a:p>
+            <a:r>
+              <a:rPr lang="fr-FR" dirty="0" err="1"/>
+              <a:t>Epochs</a:t>
+            </a:r>
+            <a:endParaRPr lang="fr-FR" dirty="0"/>
+          </a:p>
+          <a:p>
+            <a:pPr lvl="1"/>
+            <a:r>
+              <a:rPr lang="fr-FR" dirty="0"/>
+              <a:t>Nombre d'itération sur le </a:t>
+            </a:r>
+            <a:r>
+              <a:rPr lang="fr-FR" dirty="0" err="1"/>
+              <a:t>dataset</a:t>
+            </a:r>
+            <a:endParaRPr lang="fr-FR" dirty="0"/>
+          </a:p>
+          <a:p>
+            <a:pPr lvl="1"/>
+            <a:r>
+              <a:rPr lang="fr-FR" dirty="0"/>
+              <a:t>2 minimum</a:t>
+            </a:r>
+          </a:p>
+          <a:p>
+            <a:r>
+              <a:rPr lang="fr-FR" dirty="0" err="1"/>
+              <a:t>Trainable</a:t>
+            </a:r>
+            <a:endParaRPr lang="fr-FR" dirty="0"/>
+          </a:p>
+          <a:p>
+            <a:pPr lvl="1"/>
+            <a:r>
+              <a:rPr lang="fr-FR" dirty="0"/>
+              <a:t>Possibilité de geler les </a:t>
+            </a:r>
+            <a:r>
+              <a:rPr lang="fr-FR" dirty="0" err="1"/>
+              <a:t>layers</a:t>
+            </a:r>
+            <a:r>
+              <a:rPr lang="fr-FR" dirty="0"/>
+              <a:t> proches des inputs</a:t>
+            </a:r>
+          </a:p>
+          <a:p>
+            <a:r>
+              <a:rPr lang="fr-FR" dirty="0"/>
+              <a:t>Petit modèle</a:t>
+            </a:r>
+          </a:p>
+          <a:p>
+            <a:pPr lvl="1"/>
+            <a:r>
+              <a:rPr lang="fr-FR" dirty="0"/>
+              <a:t>Paradoxalement un petit modèle marchera mieux qu'un grand</a:t>
+            </a:r>
+          </a:p>
+          <a:p>
+            <a:pPr lvl="1"/>
+            <a:r>
+              <a:rPr lang="fr-FR" dirty="0"/>
+              <a:t>Car convergera plus vite</a:t>
+            </a:r>
+          </a:p>
+          <a:p>
+            <a:pPr lvl="1"/>
+            <a:endParaRPr lang="fr-FR" dirty="0"/>
+          </a:p>
+        </p:txBody>
+      </p:sp>
+    </p:spTree>
+    <p:extLst>
+      <p:ext uri="{BB962C8B-B14F-4D97-AF65-F5344CB8AC3E}">
+        <p14:creationId xmlns:p14="http://schemas.microsoft.com/office/powerpoint/2010/main" val="1842476340"/>
+      </p:ext>
+    </p:extLst>
+  </p:cSld>
+  <p:clrMapOvr>
+    <a:masterClrMapping/>
+  </p:clrMapOvr>
+</p:sld>
+</file>
+
+<file path=ppt/slides/slide19.xml><?xml version="1.0" encoding="utf-8"?>
+<p:sld xmlns:a="http://schemas.openxmlformats.org/drawingml/2006/main" xmlns:r="http://schemas.openxmlformats.org/officeDocument/2006/relationships" xmlns:p="http://schemas.openxmlformats.org/presentationml/2006/main">
+  <p:cSld>
+    <p:spTree>
+      <p:nvGrpSpPr>
+        <p:cNvPr id="1" name=""/>
+        <p:cNvGrpSpPr/>
+        <p:nvPr/>
+      </p:nvGrpSpPr>
+      <p:grpSpPr>
+        <a:xfrm>
+          <a:off x="0" y="0"/>
+          <a:ext cx="0" cy="0"/>
+          <a:chOff x="0" y="0"/>
+          <a:chExt cx="0" cy="0"/>
+        </a:xfrm>
+      </p:grpSpPr>
+      <p:sp>
+        <p:nvSpPr>
+          <p:cNvPr id="2" name="Titre 1">
+            <a:extLst>
+              <a:ext uri="{FF2B5EF4-FFF2-40B4-BE49-F238E27FC236}">
+                <a16:creationId xmlns:a16="http://schemas.microsoft.com/office/drawing/2014/main" id="{1A1E81D1-E936-2C8D-D5CA-2B2682789F53}"/>
+              </a:ext>
+            </a:extLst>
+          </p:cNvPr>
+          <p:cNvSpPr>
+            <a:spLocks noGrp="1"/>
+          </p:cNvSpPr>
+          <p:nvPr>
+            <p:ph type="title"/>
+          </p:nvPr>
+        </p:nvSpPr>
+        <p:spPr/>
+        <p:txBody>
+          <a:bodyPr/>
+          <a:lstStyle/>
+          <a:p>
+            <a:r>
+              <a:rPr lang="fr-FR" dirty="0"/>
+              <a:t>LLM SaaS</a:t>
+            </a:r>
+          </a:p>
+        </p:txBody>
+      </p:sp>
+      <p:sp>
+        <p:nvSpPr>
+          <p:cNvPr id="3" name="Espace réservé du contenu 2">
+            <a:extLst>
+              <a:ext uri="{FF2B5EF4-FFF2-40B4-BE49-F238E27FC236}">
+                <a16:creationId xmlns:a16="http://schemas.microsoft.com/office/drawing/2014/main" id="{5DD711A3-ACFC-5D18-64E6-849A6F60230E}"/>
+              </a:ext>
+            </a:extLst>
+          </p:cNvPr>
+          <p:cNvSpPr>
+            <a:spLocks noGrp="1"/>
+          </p:cNvSpPr>
+          <p:nvPr>
+            <p:ph idx="1"/>
+          </p:nvPr>
+        </p:nvSpPr>
+        <p:spPr/>
+        <p:txBody>
+          <a:bodyPr/>
+          <a:lstStyle/>
+          <a:p>
+            <a:r>
+              <a:rPr lang="fr-FR" dirty="0"/>
+              <a:t>Pour un LLM SaaS de type </a:t>
+            </a:r>
+            <a:r>
+              <a:rPr lang="fr-FR" dirty="0" err="1"/>
+              <a:t>OpenAI</a:t>
+            </a:r>
+            <a:r>
+              <a:rPr lang="fr-FR" dirty="0"/>
+              <a:t> ou Mistral.ai</a:t>
+            </a:r>
+          </a:p>
+          <a:p>
+            <a:pPr lvl="1"/>
+            <a:r>
+              <a:rPr lang="fr-FR" dirty="0"/>
+              <a:t>Utiliser les outils ou API du fournisseur</a:t>
+            </a:r>
+          </a:p>
+          <a:p>
+            <a:pPr lvl="1"/>
+            <a:r>
+              <a:rPr lang="fr-FR" dirty="0"/>
+              <a:t>API </a:t>
+            </a:r>
+            <a:r>
+              <a:rPr lang="fr-FR" dirty="0" err="1"/>
+              <a:t>HuggingFace</a:t>
+            </a:r>
+            <a:r>
+              <a:rPr lang="fr-FR" dirty="0"/>
+              <a:t> également</a:t>
+            </a:r>
+          </a:p>
+          <a:p>
+            <a:pPr lvl="1"/>
+            <a:r>
+              <a:rPr lang="fr-FR" dirty="0"/>
+              <a:t>Voir exemple Mistral</a:t>
+            </a:r>
+          </a:p>
+          <a:p>
+            <a:r>
+              <a:rPr lang="fr-FR" dirty="0"/>
+              <a:t>Pour un LLM on promise</a:t>
+            </a:r>
+          </a:p>
+          <a:p>
+            <a:pPr lvl="1"/>
+            <a:r>
+              <a:rPr lang="fr-FR" dirty="0"/>
+              <a:t>Utilisation possible de </a:t>
+            </a:r>
+            <a:r>
+              <a:rPr lang="fr-FR" dirty="0" err="1"/>
+              <a:t>langchain</a:t>
+            </a:r>
+            <a:endParaRPr lang="fr-FR" dirty="0"/>
+          </a:p>
+          <a:p>
+            <a:pPr lvl="1"/>
+            <a:r>
+              <a:rPr lang="fr-FR" dirty="0"/>
+              <a:t>Nécessite un GPU</a:t>
+            </a:r>
+          </a:p>
+          <a:p>
+            <a:pPr lvl="1"/>
+            <a:r>
+              <a:rPr lang="fr-FR" dirty="0"/>
+              <a:t>En fonction du modèle de 1h à 1 semaine de calcul</a:t>
+            </a:r>
+          </a:p>
+        </p:txBody>
+      </p:sp>
+    </p:spTree>
+    <p:extLst>
+      <p:ext uri="{BB962C8B-B14F-4D97-AF65-F5344CB8AC3E}">
+        <p14:creationId xmlns:p14="http://schemas.microsoft.com/office/powerpoint/2010/main" val="3752228764"/>
+      </p:ext>
+    </p:extLst>
+  </p:cSld>
+  <p:clrMapOvr>
+    <a:masterClrMapping/>
+  </p:clrMapOvr>
+</p:sld>
+</file>
+
 <file path=ppt/slides/slide2.xml><?xml version="1.0" encoding="utf-8"?>
 <p:sld xmlns:a="http://schemas.openxmlformats.org/drawingml/2006/main" xmlns:r="http://schemas.openxmlformats.org/officeDocument/2006/relationships" xmlns:p="http://schemas.openxmlformats.org/presentationml/2006/main">
   <p:cSld>
@@ -4721,6 +5350,670 @@
     <p:extLst>
       <p:ext uri="{BB962C8B-B14F-4D97-AF65-F5344CB8AC3E}">
         <p14:creationId xmlns:p14="http://schemas.microsoft.com/office/powerpoint/2010/main" val="1167108909"/>
+      </p:ext>
+    </p:extLst>
+  </p:cSld>
+  <p:clrMapOvr>
+    <a:masterClrMapping/>
+  </p:clrMapOvr>
+</p:sld>
+</file>
+
+<file path=ppt/slides/slide20.xml><?xml version="1.0" encoding="utf-8"?>
+<p:sld xmlns:a="http://schemas.openxmlformats.org/drawingml/2006/main" xmlns:r="http://schemas.openxmlformats.org/officeDocument/2006/relationships" xmlns:p="http://schemas.openxmlformats.org/presentationml/2006/main">
+  <p:cSld>
+    <p:spTree>
+      <p:nvGrpSpPr>
+        <p:cNvPr id="1" name=""/>
+        <p:cNvGrpSpPr/>
+        <p:nvPr/>
+      </p:nvGrpSpPr>
+      <p:grpSpPr>
+        <a:xfrm>
+          <a:off x="0" y="0"/>
+          <a:ext cx="0" cy="0"/>
+          <a:chOff x="0" y="0"/>
+          <a:chExt cx="0" cy="0"/>
+        </a:xfrm>
+      </p:grpSpPr>
+      <p:sp>
+        <p:nvSpPr>
+          <p:cNvPr id="2" name="Titre 1">
+            <a:extLst>
+              <a:ext uri="{FF2B5EF4-FFF2-40B4-BE49-F238E27FC236}">
+                <a16:creationId xmlns:a16="http://schemas.microsoft.com/office/drawing/2014/main" id="{A36C85D3-863D-FD50-E988-C26AD2534E13}"/>
+              </a:ext>
+            </a:extLst>
+          </p:cNvPr>
+          <p:cNvSpPr>
+            <a:spLocks noGrp="1"/>
+          </p:cNvSpPr>
+          <p:nvPr>
+            <p:ph type="title"/>
+          </p:nvPr>
+        </p:nvSpPr>
+        <p:spPr/>
+        <p:txBody>
+          <a:bodyPr/>
+          <a:lstStyle/>
+          <a:p>
+            <a:r>
+              <a:rPr lang="fr-FR" dirty="0" err="1"/>
+              <a:t>LoRA</a:t>
+            </a:r>
+            <a:endParaRPr lang="fr-FR" dirty="0"/>
+          </a:p>
+        </p:txBody>
+      </p:sp>
+      <p:sp>
+        <p:nvSpPr>
+          <p:cNvPr id="3" name="Espace réservé du contenu 2">
+            <a:extLst>
+              <a:ext uri="{FF2B5EF4-FFF2-40B4-BE49-F238E27FC236}">
+                <a16:creationId xmlns:a16="http://schemas.microsoft.com/office/drawing/2014/main" id="{D3B91305-7970-9067-1317-69F4549F533A}"/>
+              </a:ext>
+            </a:extLst>
+          </p:cNvPr>
+          <p:cNvSpPr>
+            <a:spLocks noGrp="1"/>
+          </p:cNvSpPr>
+          <p:nvPr>
+            <p:ph idx="1"/>
+          </p:nvPr>
+        </p:nvSpPr>
+        <p:spPr>
+          <a:xfrm>
+            <a:off x="179513" y="1412776"/>
+            <a:ext cx="5479416" cy="5040560"/>
+          </a:xfrm>
+        </p:spPr>
+        <p:txBody>
+          <a:bodyPr/>
+          <a:lstStyle/>
+          <a:p>
+            <a:r>
+              <a:rPr lang="fr-FR" dirty="0"/>
+              <a:t>Low Rank Adaptation</a:t>
+            </a:r>
+          </a:p>
+          <a:p>
+            <a:r>
+              <a:rPr lang="fr-FR" sz="2000" dirty="0" err="1"/>
+              <a:t>LoRA</a:t>
+            </a:r>
+            <a:r>
+              <a:rPr lang="fr-FR" sz="2000" dirty="0"/>
+              <a:t> est une méthode d'apprentissage conçue pour accélérer l'apprentissage de grands modèles de langage, tout en réduisant la consommation de mémoire</a:t>
+            </a:r>
+          </a:p>
+          <a:p>
+            <a:r>
+              <a:rPr lang="fr-FR" sz="2000" dirty="0"/>
+              <a:t>En introduisant des paires de matrices de pondération par décomposition en rangs, appelées matrices de mise à jour, aux pondérations existantes, </a:t>
+            </a:r>
+            <a:r>
+              <a:rPr lang="fr-FR" sz="2000" dirty="0" err="1"/>
+              <a:t>LoRA</a:t>
+            </a:r>
+            <a:r>
+              <a:rPr lang="fr-FR" sz="2000" dirty="0"/>
+              <a:t> se concentre uniquement sur l'apprentissage de ces nouvelles pondérations</a:t>
+            </a:r>
+          </a:p>
+          <a:p>
+            <a:r>
+              <a:rPr lang="fr-FR" sz="2000" dirty="0"/>
+              <a:t>GPU de 48Go obligatoire</a:t>
+            </a:r>
+          </a:p>
+          <a:p>
+            <a:endParaRPr lang="fr-FR" dirty="0"/>
+          </a:p>
+        </p:txBody>
+      </p:sp>
+      <p:pic>
+        <p:nvPicPr>
+          <p:cNvPr id="4" name="Image 3">
+            <a:extLst>
+              <a:ext uri="{FF2B5EF4-FFF2-40B4-BE49-F238E27FC236}">
+                <a16:creationId xmlns:a16="http://schemas.microsoft.com/office/drawing/2014/main" id="{8412B7C8-C985-BCFA-4C5C-60844D5841B9}"/>
+              </a:ext>
+            </a:extLst>
+          </p:cNvPr>
+          <p:cNvPicPr>
+            <a:picLocks noChangeAspect="1"/>
+          </p:cNvPicPr>
+          <p:nvPr/>
+        </p:nvPicPr>
+        <p:blipFill>
+          <a:blip r:embed="rId2"/>
+          <a:stretch>
+            <a:fillRect/>
+          </a:stretch>
+        </p:blipFill>
+        <p:spPr>
+          <a:xfrm>
+            <a:off x="5658928" y="1844824"/>
+            <a:ext cx="3386364" cy="3717032"/>
+          </a:xfrm>
+          <a:prstGeom prst="rect">
+            <a:avLst/>
+          </a:prstGeom>
+        </p:spPr>
+      </p:pic>
+    </p:spTree>
+    <p:extLst>
+      <p:ext uri="{BB962C8B-B14F-4D97-AF65-F5344CB8AC3E}">
+        <p14:creationId xmlns:p14="http://schemas.microsoft.com/office/powerpoint/2010/main" val="205216239"/>
+      </p:ext>
+    </p:extLst>
+  </p:cSld>
+  <p:clrMapOvr>
+    <a:masterClrMapping/>
+  </p:clrMapOvr>
+</p:sld>
+</file>
+
+<file path=ppt/slides/slide21.xml><?xml version="1.0" encoding="utf-8"?>
+<p:sld xmlns:a="http://schemas.openxmlformats.org/drawingml/2006/main" xmlns:r="http://schemas.openxmlformats.org/officeDocument/2006/relationships" xmlns:p="http://schemas.openxmlformats.org/presentationml/2006/main">
+  <p:cSld>
+    <p:spTree>
+      <p:nvGrpSpPr>
+        <p:cNvPr id="1" name=""/>
+        <p:cNvGrpSpPr/>
+        <p:nvPr/>
+      </p:nvGrpSpPr>
+      <p:grpSpPr>
+        <a:xfrm>
+          <a:off x="0" y="0"/>
+          <a:ext cx="0" cy="0"/>
+          <a:chOff x="0" y="0"/>
+          <a:chExt cx="0" cy="0"/>
+        </a:xfrm>
+      </p:grpSpPr>
+      <p:sp>
+        <p:nvSpPr>
+          <p:cNvPr id="2" name="Titre 1">
+            <a:extLst>
+              <a:ext uri="{FF2B5EF4-FFF2-40B4-BE49-F238E27FC236}">
+                <a16:creationId xmlns:a16="http://schemas.microsoft.com/office/drawing/2014/main" id="{085AB4CD-50F7-E19D-2942-27F347D58E63}"/>
+              </a:ext>
+            </a:extLst>
+          </p:cNvPr>
+          <p:cNvSpPr>
+            <a:spLocks noGrp="1"/>
+          </p:cNvSpPr>
+          <p:nvPr>
+            <p:ph type="title"/>
+          </p:nvPr>
+        </p:nvSpPr>
+        <p:spPr/>
+        <p:txBody>
+          <a:bodyPr/>
+          <a:lstStyle/>
+          <a:p>
+            <a:r>
+              <a:rPr lang="fr-FR" dirty="0" err="1"/>
+              <a:t>LoRA</a:t>
+            </a:r>
+            <a:endParaRPr lang="fr-FR" dirty="0"/>
+          </a:p>
+        </p:txBody>
+      </p:sp>
+      <p:sp>
+        <p:nvSpPr>
+          <p:cNvPr id="3" name="Espace réservé du contenu 2">
+            <a:extLst>
+              <a:ext uri="{FF2B5EF4-FFF2-40B4-BE49-F238E27FC236}">
+                <a16:creationId xmlns:a16="http://schemas.microsoft.com/office/drawing/2014/main" id="{2F649A8B-5BF8-435D-BB8D-15EC190D081F}"/>
+              </a:ext>
+            </a:extLst>
+          </p:cNvPr>
+          <p:cNvSpPr>
+            <a:spLocks noGrp="1"/>
+          </p:cNvSpPr>
+          <p:nvPr>
+            <p:ph idx="1"/>
+          </p:nvPr>
+        </p:nvSpPr>
+        <p:spPr/>
+        <p:txBody>
+          <a:bodyPr/>
+          <a:lstStyle/>
+          <a:p>
+            <a:endParaRPr lang="fr-FR"/>
+          </a:p>
+        </p:txBody>
+      </p:sp>
+      <p:pic>
+        <p:nvPicPr>
+          <p:cNvPr id="5" name="Image 4">
+            <a:extLst>
+              <a:ext uri="{FF2B5EF4-FFF2-40B4-BE49-F238E27FC236}">
+                <a16:creationId xmlns:a16="http://schemas.microsoft.com/office/drawing/2014/main" id="{591D2084-09CA-F63C-27D6-F0AC94078800}"/>
+              </a:ext>
+            </a:extLst>
+          </p:cNvPr>
+          <p:cNvPicPr>
+            <a:picLocks noChangeAspect="1"/>
+          </p:cNvPicPr>
+          <p:nvPr/>
+        </p:nvPicPr>
+        <p:blipFill>
+          <a:blip r:embed="rId2"/>
+          <a:stretch>
+            <a:fillRect/>
+          </a:stretch>
+        </p:blipFill>
+        <p:spPr>
+          <a:xfrm>
+            <a:off x="1554683" y="1156209"/>
+            <a:ext cx="6401693" cy="5287113"/>
+          </a:xfrm>
+          <a:prstGeom prst="rect">
+            <a:avLst/>
+          </a:prstGeom>
+        </p:spPr>
+      </p:pic>
+    </p:spTree>
+    <p:extLst>
+      <p:ext uri="{BB962C8B-B14F-4D97-AF65-F5344CB8AC3E}">
+        <p14:creationId xmlns:p14="http://schemas.microsoft.com/office/powerpoint/2010/main" val="1510836556"/>
+      </p:ext>
+    </p:extLst>
+  </p:cSld>
+  <p:clrMapOvr>
+    <a:masterClrMapping/>
+  </p:clrMapOvr>
+</p:sld>
+</file>
+
+<file path=ppt/slides/slide22.xml><?xml version="1.0" encoding="utf-8"?>
+<p:sld xmlns:a="http://schemas.openxmlformats.org/drawingml/2006/main" xmlns:r="http://schemas.openxmlformats.org/officeDocument/2006/relationships" xmlns:p="http://schemas.openxmlformats.org/presentationml/2006/main">
+  <p:cSld>
+    <p:spTree>
+      <p:nvGrpSpPr>
+        <p:cNvPr id="1" name=""/>
+        <p:cNvGrpSpPr/>
+        <p:nvPr/>
+      </p:nvGrpSpPr>
+      <p:grpSpPr>
+        <a:xfrm>
+          <a:off x="0" y="0"/>
+          <a:ext cx="0" cy="0"/>
+          <a:chOff x="0" y="0"/>
+          <a:chExt cx="0" cy="0"/>
+        </a:xfrm>
+      </p:grpSpPr>
+      <p:sp>
+        <p:nvSpPr>
+          <p:cNvPr id="2" name="Titre 1">
+            <a:extLst>
+              <a:ext uri="{FF2B5EF4-FFF2-40B4-BE49-F238E27FC236}">
+                <a16:creationId xmlns:a16="http://schemas.microsoft.com/office/drawing/2014/main" id="{80BD19AE-78B6-6A52-810D-37098401EF85}"/>
+              </a:ext>
+            </a:extLst>
+          </p:cNvPr>
+          <p:cNvSpPr>
+            <a:spLocks noGrp="1"/>
+          </p:cNvSpPr>
+          <p:nvPr>
+            <p:ph type="title"/>
+          </p:nvPr>
+        </p:nvSpPr>
+        <p:spPr/>
+        <p:txBody>
+          <a:bodyPr/>
+          <a:lstStyle/>
+          <a:p>
+            <a:endParaRPr lang="fr-FR"/>
+          </a:p>
+        </p:txBody>
+      </p:sp>
+      <p:sp>
+        <p:nvSpPr>
+          <p:cNvPr id="3" name="Espace réservé du contenu 2">
+            <a:extLst>
+              <a:ext uri="{FF2B5EF4-FFF2-40B4-BE49-F238E27FC236}">
+                <a16:creationId xmlns:a16="http://schemas.microsoft.com/office/drawing/2014/main" id="{3BEAAC46-AEF0-53BE-FBF3-C9C31FD31061}"/>
+              </a:ext>
+            </a:extLst>
+          </p:cNvPr>
+          <p:cNvSpPr>
+            <a:spLocks noGrp="1"/>
+          </p:cNvSpPr>
+          <p:nvPr>
+            <p:ph idx="1"/>
+          </p:nvPr>
+        </p:nvSpPr>
+        <p:spPr/>
+        <p:txBody>
+          <a:bodyPr/>
+          <a:lstStyle/>
+          <a:p>
+            <a:endParaRPr lang="fr-FR"/>
+          </a:p>
+        </p:txBody>
+      </p:sp>
+      <p:pic>
+        <p:nvPicPr>
+          <p:cNvPr id="1026" name="Picture 2" descr="Full-model Fine-tuning vs. LoRA vs. RAG | by Somanath diksangi | Oct, 2025  | Medium">
+            <a:extLst>
+              <a:ext uri="{FF2B5EF4-FFF2-40B4-BE49-F238E27FC236}">
+                <a16:creationId xmlns:a16="http://schemas.microsoft.com/office/drawing/2014/main" id="{DB16A888-694E-77E8-3547-2A77A979870B}"/>
+              </a:ext>
+            </a:extLst>
+          </p:cNvPr>
+          <p:cNvPicPr>
+            <a:picLocks noChangeAspect="1" noChangeArrowheads="1"/>
+          </p:cNvPicPr>
+          <p:nvPr/>
+        </p:nvPicPr>
+        <p:blipFill>
+          <a:blip r:embed="rId2">
+            <a:extLst>
+              <a:ext uri="{28A0092B-C50C-407E-A947-70E740481C1C}">
+                <a14:useLocalDpi xmlns:a14="http://schemas.microsoft.com/office/drawing/2010/main" val="0"/>
+              </a:ext>
+            </a:extLst>
+          </a:blip>
+          <a:srcRect/>
+          <a:stretch>
+            <a:fillRect/>
+          </a:stretch>
+        </p:blipFill>
+        <p:spPr bwMode="auto">
+          <a:xfrm>
+            <a:off x="1763713" y="0"/>
+            <a:ext cx="5616575" cy="6858000"/>
+          </a:xfrm>
+          <a:prstGeom prst="rect">
+            <a:avLst/>
+          </a:prstGeom>
+          <a:noFill/>
+          <a:extLst>
+            <a:ext uri="{909E8E84-426E-40DD-AFC4-6F175D3DCCD1}">
+              <a14:hiddenFill xmlns:a14="http://schemas.microsoft.com/office/drawing/2010/main">
+                <a:solidFill>
+                  <a:srgbClr val="FFFFFF"/>
+                </a:solidFill>
+              </a14:hiddenFill>
+            </a:ext>
+          </a:extLst>
+        </p:spPr>
+      </p:pic>
+    </p:spTree>
+    <p:extLst>
+      <p:ext uri="{BB962C8B-B14F-4D97-AF65-F5344CB8AC3E}">
+        <p14:creationId xmlns:p14="http://schemas.microsoft.com/office/powerpoint/2010/main" val="3398122075"/>
+      </p:ext>
+    </p:extLst>
+  </p:cSld>
+  <p:clrMapOvr>
+    <a:masterClrMapping/>
+  </p:clrMapOvr>
+</p:sld>
+</file>
+
+<file path=ppt/slides/slide23.xml><?xml version="1.0" encoding="utf-8"?>
+<p:sld xmlns:a="http://schemas.openxmlformats.org/drawingml/2006/main" xmlns:r="http://schemas.openxmlformats.org/officeDocument/2006/relationships" xmlns:p="http://schemas.openxmlformats.org/presentationml/2006/main">
+  <p:cSld>
+    <p:spTree>
+      <p:nvGrpSpPr>
+        <p:cNvPr id="1" name=""/>
+        <p:cNvGrpSpPr/>
+        <p:nvPr/>
+      </p:nvGrpSpPr>
+      <p:grpSpPr>
+        <a:xfrm>
+          <a:off x="0" y="0"/>
+          <a:ext cx="0" cy="0"/>
+          <a:chOff x="0" y="0"/>
+          <a:chExt cx="0" cy="0"/>
+        </a:xfrm>
+      </p:grpSpPr>
+      <p:sp>
+        <p:nvSpPr>
+          <p:cNvPr id="2" name="Titre 1">
+            <a:extLst>
+              <a:ext uri="{FF2B5EF4-FFF2-40B4-BE49-F238E27FC236}">
+                <a16:creationId xmlns:a16="http://schemas.microsoft.com/office/drawing/2014/main" id="{F118909D-F04D-6E31-5C67-54F753EC11D2}"/>
+              </a:ext>
+            </a:extLst>
+          </p:cNvPr>
+          <p:cNvSpPr>
+            <a:spLocks noGrp="1"/>
+          </p:cNvSpPr>
+          <p:nvPr>
+            <p:ph type="title"/>
+          </p:nvPr>
+        </p:nvSpPr>
+        <p:spPr/>
+        <p:txBody>
+          <a:bodyPr/>
+          <a:lstStyle/>
+          <a:p>
+            <a:r>
+              <a:rPr lang="fr-FR" dirty="0" err="1"/>
+              <a:t>LoRA</a:t>
+            </a:r>
+            <a:endParaRPr lang="fr-FR" dirty="0"/>
+          </a:p>
+        </p:txBody>
+      </p:sp>
+      <p:sp>
+        <p:nvSpPr>
+          <p:cNvPr id="3" name="Espace réservé du contenu 2">
+            <a:extLst>
+              <a:ext uri="{FF2B5EF4-FFF2-40B4-BE49-F238E27FC236}">
+                <a16:creationId xmlns:a16="http://schemas.microsoft.com/office/drawing/2014/main" id="{91E8B70C-3BAC-7C3B-F538-C6F5B6281541}"/>
+              </a:ext>
+            </a:extLst>
+          </p:cNvPr>
+          <p:cNvSpPr>
+            <a:spLocks noGrp="1"/>
+          </p:cNvSpPr>
+          <p:nvPr>
+            <p:ph idx="1"/>
+          </p:nvPr>
+        </p:nvSpPr>
+        <p:spPr/>
+        <p:txBody>
+          <a:bodyPr/>
+          <a:lstStyle/>
+          <a:p>
+            <a:r>
+              <a:rPr lang="fr-FR" dirty="0"/>
+              <a:t>Paramètres </a:t>
+            </a:r>
+            <a:r>
+              <a:rPr lang="fr-FR" dirty="0" err="1"/>
+              <a:t>LoRA</a:t>
+            </a:r>
+            <a:endParaRPr lang="fr-FR" dirty="0"/>
+          </a:p>
+          <a:p>
+            <a:r>
+              <a:rPr lang="fr-FR" dirty="0"/>
+              <a:t>Rank</a:t>
+            </a:r>
+          </a:p>
+          <a:p>
+            <a:pPr lvl="1"/>
+            <a:r>
+              <a:rPr lang="fr-FR" dirty="0"/>
+              <a:t>Nombre de matrice de décomposition</a:t>
+            </a:r>
+          </a:p>
+          <a:p>
+            <a:pPr lvl="1"/>
+            <a:r>
+              <a:rPr lang="fr-FR" dirty="0" err="1"/>
+              <a:t>rank</a:t>
+            </a:r>
+            <a:r>
+              <a:rPr lang="fr-FR" dirty="0"/>
+              <a:t>=8 conseillé</a:t>
+            </a:r>
+          </a:p>
+          <a:p>
+            <a:r>
+              <a:rPr lang="fr-FR" dirty="0"/>
+              <a:t>Alpha</a:t>
+            </a:r>
+          </a:p>
+          <a:p>
+            <a:pPr lvl="1"/>
+            <a:r>
+              <a:rPr lang="fr-FR" dirty="0"/>
+              <a:t>Facteur d'échelle</a:t>
+            </a:r>
+          </a:p>
+          <a:p>
+            <a:pPr lvl="1"/>
+            <a:r>
+              <a:rPr lang="fr-FR" dirty="0"/>
+              <a:t>Pondération de la matrice de décomposition par rapport au LLM</a:t>
+            </a:r>
+          </a:p>
+          <a:p>
+            <a:pPr lvl="1"/>
+            <a:r>
+              <a:rPr lang="fr-FR" dirty="0"/>
+              <a:t>Alpha fort = adaptation importante par rapport au modèle d'origine</a:t>
+            </a:r>
+          </a:p>
+        </p:txBody>
+      </p:sp>
+    </p:spTree>
+    <p:extLst>
+      <p:ext uri="{BB962C8B-B14F-4D97-AF65-F5344CB8AC3E}">
+        <p14:creationId xmlns:p14="http://schemas.microsoft.com/office/powerpoint/2010/main" val="1924057042"/>
+      </p:ext>
+    </p:extLst>
+  </p:cSld>
+  <p:clrMapOvr>
+    <a:masterClrMapping/>
+  </p:clrMapOvr>
+</p:sld>
+</file>
+
+<file path=ppt/slides/slide24.xml><?xml version="1.0" encoding="utf-8"?>
+<p:sld xmlns:a="http://schemas.openxmlformats.org/drawingml/2006/main" xmlns:r="http://schemas.openxmlformats.org/officeDocument/2006/relationships" xmlns:p="http://schemas.openxmlformats.org/presentationml/2006/main">
+  <p:cSld>
+    <p:spTree>
+      <p:nvGrpSpPr>
+        <p:cNvPr id="1" name=""/>
+        <p:cNvGrpSpPr/>
+        <p:nvPr/>
+      </p:nvGrpSpPr>
+      <p:grpSpPr>
+        <a:xfrm>
+          <a:off x="0" y="0"/>
+          <a:ext cx="0" cy="0"/>
+          <a:chOff x="0" y="0"/>
+          <a:chExt cx="0" cy="0"/>
+        </a:xfrm>
+      </p:grpSpPr>
+      <p:sp>
+        <p:nvSpPr>
+          <p:cNvPr id="2" name="Titre 1">
+            <a:extLst>
+              <a:ext uri="{FF2B5EF4-FFF2-40B4-BE49-F238E27FC236}">
+                <a16:creationId xmlns:a16="http://schemas.microsoft.com/office/drawing/2014/main" id="{9F2B7D5D-9B4A-83B0-407E-417EFCF611C5}"/>
+              </a:ext>
+            </a:extLst>
+          </p:cNvPr>
+          <p:cNvSpPr>
+            <a:spLocks noGrp="1"/>
+          </p:cNvSpPr>
+          <p:nvPr>
+            <p:ph type="title"/>
+          </p:nvPr>
+        </p:nvSpPr>
+        <p:spPr/>
+        <p:txBody>
+          <a:bodyPr/>
+          <a:lstStyle/>
+          <a:p>
+            <a:r>
+              <a:rPr lang="fr-FR" dirty="0" err="1"/>
+              <a:t>QLora</a:t>
+            </a:r>
+            <a:endParaRPr lang="fr-FR" dirty="0"/>
+          </a:p>
+        </p:txBody>
+      </p:sp>
+      <p:sp>
+        <p:nvSpPr>
+          <p:cNvPr id="3" name="Espace réservé du contenu 2">
+            <a:extLst>
+              <a:ext uri="{FF2B5EF4-FFF2-40B4-BE49-F238E27FC236}">
+                <a16:creationId xmlns:a16="http://schemas.microsoft.com/office/drawing/2014/main" id="{473DDB84-EB90-C947-F8F2-527AC9F0E246}"/>
+              </a:ext>
+            </a:extLst>
+          </p:cNvPr>
+          <p:cNvSpPr>
+            <a:spLocks noGrp="1"/>
+          </p:cNvSpPr>
+          <p:nvPr>
+            <p:ph idx="1"/>
+          </p:nvPr>
+        </p:nvSpPr>
+        <p:spPr/>
+        <p:txBody>
+          <a:bodyPr/>
+          <a:lstStyle/>
+          <a:p>
+            <a:r>
+              <a:rPr lang="fr-FR" dirty="0" err="1"/>
+              <a:t>Quantization</a:t>
+            </a:r>
+            <a:endParaRPr lang="fr-FR" dirty="0"/>
+          </a:p>
+          <a:p>
+            <a:pPr lvl="1"/>
+            <a:r>
+              <a:rPr lang="fr-FR" dirty="0"/>
+              <a:t>Par défaut les poids sont des float32</a:t>
+            </a:r>
+          </a:p>
+          <a:p>
+            <a:pPr lvl="1"/>
+            <a:r>
+              <a:rPr lang="fr-FR" dirty="0"/>
+              <a:t>Passage des poids en float16</a:t>
+            </a:r>
+          </a:p>
+          <a:p>
+            <a:pPr lvl="1"/>
+            <a:r>
+              <a:rPr lang="fr-FR" dirty="0"/>
+              <a:t>Les poids </a:t>
+            </a:r>
+            <a:r>
+              <a:rPr lang="fr-FR" dirty="0" err="1"/>
+              <a:t>Qlora</a:t>
+            </a:r>
+            <a:r>
+              <a:rPr lang="fr-FR" dirty="0"/>
+              <a:t> peuvent </a:t>
+            </a:r>
+            <a:r>
+              <a:rPr lang="fr-FR" dirty="0" err="1"/>
+              <a:t>décendre</a:t>
+            </a:r>
+            <a:r>
+              <a:rPr lang="fr-FR" dirty="0"/>
+              <a:t> à NF4 (équivalent d'un float4)</a:t>
+            </a:r>
+          </a:p>
+        </p:txBody>
+      </p:sp>
+    </p:spTree>
+    <p:extLst>
+      <p:ext uri="{BB962C8B-B14F-4D97-AF65-F5344CB8AC3E}">
+        <p14:creationId xmlns:p14="http://schemas.microsoft.com/office/powerpoint/2010/main" val="1148820270"/>
       </p:ext>
     </p:extLst>
   </p:cSld>

</xml_diff>